<commit_message>
recording the presentation and adding it to the repository
</commit_message>
<xml_diff>
--- a/Do Fairness Benchmarks Agree Project Presentation.pptx
+++ b/Do Fairness Benchmarks Agree Project Presentation.pptx
@@ -290,11 +290,7 @@
           <a:bodyPr/>
           <a:lstStyle/>
           <a:p>
-            <a:r>
-              <a:rPr lang="en-US" dirty="0"/>
-              <a:t>Suggested timing: 1 minute.
-Open by framing the presentation around a practical question: when we say a system is fair, do our fairness benchmarks actually agree? Then introduce yourself, the course, and the project category. Briefly preview that the presentation moves from motivation, to workflow, to corrected results, and then to the implications for reproducible fairness auditing.</a:t>
-            </a:r>
+            <a:endParaRPr lang="en-US" dirty="0"/>
           </a:p>
         </p:txBody>
       </p:sp>
@@ -462,11 +458,7 @@
           <a:bodyPr/>
           <a:lstStyle/>
           <a:p>
-            <a:r>
-              <a:rPr lang="en-US" dirty="0"/>
-              <a:t>Suggested timing: 1.5 minutes.
-Explain that fairness is multi-dimensional. A model can look fine if only one number is reported, yet that same model may look different when the audit focuses on allocation, error behavior, or the meaning of positive predictions. Emphasize that the project moves from a one-number mindset to a structured audit that combines multiple metrics, uncertainty, agreement analysis, and documentation.</a:t>
-            </a:r>
+            <a:endParaRPr lang="en-US" dirty="0"/>
           </a:p>
         </p:txBody>
       </p:sp>
@@ -1305,7 +1297,7 @@
           </a:prstGeom>
           <a:extLst>
             <a:ext uri="{C572A759-6A51-4108-AA02-DFA0A04FC94B}">
-              <ma14:wrappingTextBoxFlag xmlns="" xmlns:ma14="http://schemas.microsoft.com/office/mac/drawingml/2011/main" val="0"/>
+              <ma14:wrappingTextBoxFlag xmlns:ma14="http://schemas.microsoft.com/office/mac/drawingml/2011/main" xmlns="" val="0"/>
             </a:ext>
           </a:extLst>
         </p:spPr>
@@ -2118,7 +2110,7 @@
           </a:prstGeom>
           <a:extLst>
             <a:ext uri="{C572A759-6A51-4108-AA02-DFA0A04FC94B}">
-              <ma14:wrappingTextBoxFlag xmlns="" xmlns:ma14="http://schemas.microsoft.com/office/mac/drawingml/2011/main" val="0"/>
+              <ma14:wrappingTextBoxFlag xmlns:ma14="http://schemas.microsoft.com/office/mac/drawingml/2011/main" xmlns="" val="0"/>
             </a:ext>
           </a:extLst>
         </p:spPr>
@@ -3842,7 +3834,7 @@
           </a:prstGeom>
           <a:extLst>
             <a:ext uri="{C572A759-6A51-4108-AA02-DFA0A04FC94B}">
-              <ma14:wrappingTextBoxFlag xmlns="" xmlns:ma14="http://schemas.microsoft.com/office/mac/drawingml/2011/main" val="0"/>
+              <ma14:wrappingTextBoxFlag xmlns:ma14="http://schemas.microsoft.com/office/mac/drawingml/2011/main" xmlns="" val="0"/>
             </a:ext>
           </a:extLst>
         </p:spPr>

</xml_diff>